<commit_message>
Rebuild as a translation of the OpenEpoch Chinese deck
Same diagrams, English text, trimmed to ten pages. Nova: the Chinese deck was
already drawn well, don't redraw it.

Co-Authored-By: Claude Opus 5 <noreply@anthropic.com>
</commit_message>
<xml_diff>
--- a/ef5aabaf9c89/Vishwa_Pitch_2026-09-06.pptx
+++ b/ef5aabaf9c89/Vishwa_Pitch_2026-09-06.pptx
@@ -24,7 +24,6 @@
     <p:sldId id="272" r:id="rId23"/>
     <p:sldId id="273" r:id="rId24"/>
     <p:sldId id="274" r:id="rId25"/>
-    <p:sldId id="275" r:id="rId26"/>
   </p:sldIdLst>
   <p:sldSz cx="12191695" cy="6858000" type="screen4x3"/>
   <p:notesSz cx="6858000" cy="9144000"/>
@@ -3601,48 +3600,6 @@
 </p:sld>
 </file>
 
-<file path=ppt/slides/slide20.xml><?xml version="1.0" encoding="utf-8"?>
-<p:sld xmlns:a="http://schemas.openxmlformats.org/drawingml/2006/main" xmlns:p="http://schemas.openxmlformats.org/presentationml/2006/main" xmlns:r="http://schemas.openxmlformats.org/officeDocument/2006/relationships">
-  <p:cSld>
-    <p:spTree>
-      <p:nvGrpSpPr>
-        <p:cNvPr id="1" name=""/>
-        <p:cNvGrpSpPr/>
-        <p:nvPr/>
-      </p:nvGrpSpPr>
-      <p:grpSpPr/>
-      <p:pic>
-        <p:nvPicPr>
-          <p:cNvPr id="2" name="Picture 1" descr="slide_20.png"/>
-          <p:cNvPicPr>
-            <a:picLocks noChangeAspect="1"/>
-          </p:cNvPicPr>
-          <p:nvPr/>
-        </p:nvPicPr>
-        <p:blipFill>
-          <a:blip r:embed="rId2"/>
-          <a:stretch>
-            <a:fillRect/>
-          </a:stretch>
-        </p:blipFill>
-        <p:spPr>
-          <a:xfrm>
-            <a:off x="0" y="0"/>
-            <a:ext cx="12191695" cy="6858000"/>
-          </a:xfrm>
-          <a:prstGeom prst="rect">
-            <a:avLst/>
-          </a:prstGeom>
-        </p:spPr>
-      </p:pic>
-    </p:spTree>
-  </p:cSld>
-  <p:clrMapOvr>
-    <a:masterClrMapping/>
-  </p:clrMapOvr>
-</p:sld>
-</file>
-
 <file path=ppt/slides/slide3.xml><?xml version="1.0" encoding="utf-8"?>
 <p:sld xmlns:a="http://schemas.openxmlformats.org/drawingml/2006/main" xmlns:p="http://schemas.openxmlformats.org/presentationml/2006/main" xmlns:r="http://schemas.openxmlformats.org/officeDocument/2006/relationships">
   <p:cSld>

</xml_diff>

<commit_message>
Market page restored; global text reduction; privacy as a field grid; use of funds as bars
Co-Authored-By: Claude Opus 5 <noreply@anthropic.com>
</commit_message>
<xml_diff>
--- a/ef5aabaf9c89/Vishwa_Pitch_2026-09-06.pptx
+++ b/ef5aabaf9c89/Vishwa_Pitch_2026-09-06.pptx
@@ -24,6 +24,7 @@
     <p:sldId id="272" r:id="rId23"/>
     <p:sldId id="273" r:id="rId24"/>
     <p:sldId id="274" r:id="rId25"/>
+    <p:sldId id="275" r:id="rId26"/>
   </p:sldIdLst>
   <p:sldSz cx="12191695" cy="6858000" type="screen4x3"/>
   <p:notesSz cx="6858000" cy="9144000"/>
@@ -3600,6 +3601,48 @@
 </p:sld>
 </file>
 
+<file path=ppt/slides/slide20.xml><?xml version="1.0" encoding="utf-8"?>
+<p:sld xmlns:a="http://schemas.openxmlformats.org/drawingml/2006/main" xmlns:p="http://schemas.openxmlformats.org/presentationml/2006/main" xmlns:r="http://schemas.openxmlformats.org/officeDocument/2006/relationships">
+  <p:cSld>
+    <p:spTree>
+      <p:nvGrpSpPr>
+        <p:cNvPr id="1" name=""/>
+        <p:cNvGrpSpPr/>
+        <p:nvPr/>
+      </p:nvGrpSpPr>
+      <p:grpSpPr/>
+      <p:pic>
+        <p:nvPicPr>
+          <p:cNvPr id="2" name="Picture 1" descr="slide_20.png"/>
+          <p:cNvPicPr>
+            <a:picLocks noChangeAspect="1"/>
+          </p:cNvPicPr>
+          <p:nvPr/>
+        </p:nvPicPr>
+        <p:blipFill>
+          <a:blip r:embed="rId2"/>
+          <a:stretch>
+            <a:fillRect/>
+          </a:stretch>
+        </p:blipFill>
+        <p:spPr>
+          <a:xfrm>
+            <a:off x="0" y="0"/>
+            <a:ext cx="12191695" cy="6858000"/>
+          </a:xfrm>
+          <a:prstGeom prst="rect">
+            <a:avLst/>
+          </a:prstGeom>
+        </p:spPr>
+      </p:pic>
+    </p:spTree>
+  </p:cSld>
+  <p:clrMapOvr>
+    <a:masterClrMapping/>
+  </p:clrMapOvr>
+</p:sld>
+</file>
+
 <file path=ppt/slides/slide3.xml><?xml version="1.0" encoding="utf-8"?>
 <p:sld xmlns:a="http://schemas.openxmlformats.org/drawingml/2006/main" xmlns:p="http://schemas.openxmlformats.org/presentationml/2006/main" xmlns:r="http://schemas.openxmlformats.org/officeDocument/2006/relationships">
   <p:cSld>

</xml_diff>